<commit_message>
Preenche nome do autor e link do repositorio no relatorio e slides
</commit_message>
<xml_diff>
--- a/apresentacao_evasao.pptx
+++ b/apresentacao_evasao.pptx
@@ -1993,7 +1993,7 @@
                   <a:srgbClr val="FFFFFF"/>
                 </a:solidFill>
               </a:rPr>
-              <a:t>Aluno(a): [seu nome]      </a:t>
+              <a:t>Aluno(a): Flávia Cristina de Sousa Silva Dias Paz      </a:t>
             </a:r>
             <a:pPr indent="0" marL="0">
               <a:buNone/>
@@ -2921,7 +2921,7 @@
                 <a:ea typeface="Arial" pitchFamily="34" charset="-122"/>
                 <a:cs typeface="Arial" pitchFamily="34" charset="-120"/>
               </a:rPr>
-              <a:t>github.com/[seu-usuario]/evasao-deep-learning</a:t>
+              <a:t>github.com/fcristina72-ai/Trabalho_Final_DL</a:t>
             </a:r>
             <a:endParaRPr lang="en-US" sz="1500" dirty="0"/>
           </a:p>

</xml_diff>